<commit_message>
Module 5 phishing detective: adopt Colab run, add notebook link to deck
Co-Authored-By: Claude Opus 5.5 <noreply@anthropic.com>
</commit_message>
<xml_diff>
--- a/module-05-email-analyzer/Bandari_Ruthvik_Nath_Module5_Phishing_Detective.pptx
+++ b/module-05-email-analyzer/Bandari_Ruthvik_Nath_Module5_Phishing_Detective.pptx
@@ -861,7 +861,7 @@
           <a:lstStyle/>
           <a:p>
             <a:r>
-              <a:t>How accurate is the detector? On 3,500 test emails it had never seen, logistic regression was 98.8% accurate, with precision 0.986 and recall 0.981. It caught 1,280 of 1,305 phishing emails, missing 25, and wrongly flagged 18 of 2,195 safe emails. The random forest reached 97.7%. Duplicates were removed before the split, so the score is not inflated by the same email appearing in training and test.</a:t>
+              <a:t>How accurate is the detector? On 3,500 test emails it had never seen, logistic regression was 98.8% accurate, with precision 0.987 and recall 0.981. It caught 1,280 of 1,305 phishing emails, missing 25, and wrongly flagged 17 of 2,195 safe emails. The random forest reached 97.5%. Duplicates were removed before the split, so the score is not inflated by the same email appearing in training and test.</a:t>
             </a:r>
           </a:p>
         </p:txBody>
@@ -931,7 +931,7 @@
           <a:lstStyle/>
           <a:p>
             <a:r>
-              <a:t>Which patterns does the AI find most dangerous? The logistic regression weights show it: calls to act such as remove, click, http, site, money, and money and offer language. On the safe side are conversational words such as thanks and wrote, names and university addresses. I removed numbers and the archive names Enron and SpamAssassin from the vocabulary, because the two classes were collected in different years, but people's names and places from the safe archive still appear. That is why I treat the accuracy as valid for this dataset, not for any inbox.</a:t>
+              <a:t>Which patterns does the AI find most dangerous? The logistic regression weights show it: calls to act such as remove, click, http, site, and money and offer language. On the safe side are conversational words such as thanks and wrote, names and university addresses. I removed numbers and the archive names Enron and SpamAssassin from the vocabulary, because the two classes were collected in different years, but people's names and places from the safe archive still appear. That is why I treat the accuracy as valid for this dataset, not for any inbox.</a:t>
             </a:r>
           </a:p>
         </p:txBody>
@@ -1001,7 +1001,7 @@
           <a:lstStyle/>
           <a:p>
             <a:r>
-              <a:t>To test the system like a user would, I wrote five emails: two normal workplace messages and three scams, an account-suspension warning, a gift-card prize and a CEO-style wire-transfer request. The safety score is 100 times the model's probability that the email is safe. The safe emails scored 98 and 99, and the scams scored 2, 0, 23. The wire-transfer email has no link, so the model flagged it from its wording and length: account, length, bank, hi.</a:t>
+              <a:t>To test the system like a user would, I wrote five emails: two normal workplace messages and three scams, an account-suspension warning, a gift-card prize and a CEO-style wire-transfer request. The safety score is 100 times the model's probability that the email is safe. The safe emails scored 98 and 99, and the scams scored 2, 0, 21. The wire-transfer email has no link, so the model flagged it from its wording and length: length, account, bank, hi.</a:t>
             </a:r>
           </a:p>
         </p:txBody>
@@ -4451,7 +4451,7 @@
                 </a:solidFill>
                 <a:latin typeface="Calibri"/>
               </a:rPr>
-              <a:t>Google Colab notebook (OneDrive):</a:t>
+              <a:t>Google Colab notebook (shared link):</a:t>
             </a:r>
             <a:r>
               <a:rPr sz="1300" b="0" i="0">
@@ -4460,7 +4460,7 @@
                 </a:solidFill>
                 <a:latin typeface="Calibri"/>
               </a:rPr>
-              <a:t> [OneDrive link to be added]</a:t>
+              <a:t> https://colab.research.google.com/drive/1kLUIs3FJafw0vvu0TI55hswcTkTR9-u4?usp=sharing</a:t>
             </a:r>
           </a:p>
         </p:txBody>
@@ -4789,7 +4789,7 @@
                 </a:solidFill>
                 <a:latin typeface="Calibri"/>
               </a:rPr>
-              <a:t> Ruthvik_Nath_Bandari_Phishing_Detective.ipynb (Google Colab) · [OneDrive link to be added]</a:t>
+              <a:t> Ruthvik_Nath_Bandari_Phishing_Detective.ipynb (Google Colab) · https://colab.research.google.com/drive/1kLUIs3FJafw0vvu0TI55hswcTkTR9-u4?usp=sharing</a:t>
             </a:r>
           </a:p>
         </p:txBody>
@@ -7873,7 +7873,7 @@
         <p:spPr>
           <a:xfrm>
             <a:off x="548640" y="1600200"/>
-            <a:ext cx="7589520" cy="2589667"/>
+            <a:ext cx="7589520" cy="2583257"/>
           </a:xfrm>
           <a:prstGeom prst="rect">
             <a:avLst/>
@@ -8173,7 +8173,7 @@
                 </a:solidFill>
                 <a:latin typeface="Calibri"/>
               </a:rPr>
-              <a:t>18 of 2,195</a:t>
+              <a:t>17 of 2,195</a:t>
             </a:r>
           </a:p>
         </p:txBody>
@@ -8257,7 +8257,7 @@
                 </a:solidFill>
                 <a:latin typeface="Calibri"/>
               </a:rPr>
-              <a:t>Logistic regression beat the random forest (97.7%), and its word weights show why it flags an email.</a:t>
+              <a:t>Logistic regression beat the random forest (97.5%), and its word weights show why it flags an email.</a:t>
             </a:r>
           </a:p>
         </p:txBody>
@@ -8542,7 +8542,7 @@
         <p:spPr>
           <a:xfrm>
             <a:off x="548640" y="1691640"/>
-            <a:ext cx="6949440" cy="2840818"/>
+            <a:ext cx="6949440" cy="2843220"/>
           </a:xfrm>
           <a:prstGeom prst="rect">
             <a:avLst/>
@@ -8714,25 +8714,7 @@
                 </a:solidFill>
                 <a:latin typeface="Calibri"/>
               </a:rPr>
-              <a:t>, </a:t>
-            </a:r>
-            <a:r>
-              <a:rPr sz="1500" b="0" i="1">
-                <a:solidFill>
-                  <a:srgbClr val="1F2937"/>
-                </a:solidFill>
-                <a:latin typeface="Calibri"/>
-              </a:rPr>
-              <a:t>money</a:t>
-            </a:r>
-            <a:r>
-              <a:rPr sz="1500" b="0" i="0">
-                <a:solidFill>
-                  <a:srgbClr val="1F2937"/>
-                </a:solidFill>
-                <a:latin typeface="Calibri"/>
-              </a:rPr>
-              <a:t>: links, calls to act and offers.</a:t>
+              <a:t>: links and calls to act.</a:t>
             </a:r>
           </a:p>
           <a:p>
@@ -9137,7 +9119,7 @@
         <p:spPr>
           <a:xfrm>
             <a:off x="548640" y="1554480"/>
-            <a:ext cx="7315200" cy="2557346"/>
+            <a:ext cx="7315200" cy="2549912"/>
           </a:xfrm>
           <a:prstGeom prst="rect">
             <a:avLst/>
@@ -9372,7 +9354,7 @@
                 </a:solidFill>
                 <a:latin typeface="Calibri"/>
               </a:rPr>
-              <a:t>23</a:t>
+              <a:t>21</a:t>
             </a:r>
             <a:r>
               <a:rPr sz="1400" b="0" i="0">
@@ -9381,7 +9363,7 @@
                 </a:solidFill>
                 <a:latin typeface="Calibri"/>
               </a:rPr>
-              <a:t>; top signals: account, length, bank, hi.</a:t>
+              <a:t>; top signals: length, account, bank, hi.</a:t>
             </a:r>
           </a:p>
         </p:txBody>
@@ -9980,7 +9962,7 @@
                 </a:solidFill>
                 <a:latin typeface="Calibri"/>
               </a:rPr>
-              <a:t> scam still scored 23 from words such as </a:t>
+              <a:t> scam still scored 21 from words such as </a:t>
             </a:r>
             <a:r>
               <a:rPr sz="1500" b="0" i="1">
@@ -10462,7 +10444,7 @@
                 </a:solidFill>
                 <a:latin typeface="Calibri"/>
               </a:rPr>
-              <a:t>98.8% on unseen emails from this dataset: 98.1% of phishing caught, 18 false alarms in 2,195 safe emails.</a:t>
+              <a:t>98.8% on unseen emails from this dataset: 98.1% of phishing caught, 17 false alarms in 2,195 safe emails.</a:t>
             </a:r>
           </a:p>
         </p:txBody>

</xml_diff>

<commit_message>
Module 5 phishing detective deck: readable title link, clickable reference link, notes fix
Co-Authored-By: Claude Opus 5.5 <noreply@anthropic.com>
</commit_message>
<xml_diff>
--- a/module-05-email-analyzer/Bandari_Ruthvik_Nath_Module5_Phishing_Detective.pptx
+++ b/module-05-email-analyzer/Bandari_Ruthvik_Nath_Module5_Phishing_Detective.pptx
@@ -511,7 +511,7 @@
           <a:lstStyle/>
           <a:p>
             <a:r>
-              <a:t>This deck presents a phishing detector I built in Google Colab. It reads an email, decides whether it is phishing, and gives it a safety score from 0 to 100, like the filters in Gmail and Outlook. The full notebook, with the working model and all charts, is at the OneDrive link on this slide.</a:t>
+              <a:t>This deck presents a phishing detector I built in Google Colab. It reads an email, decides whether it is phishing, and gives it a safety score from 0 to 100, like the filters in Gmail and Outlook. The full notebook, with the working model and all charts, is at the Google Colab link on this slide.</a:t>
             </a:r>
           </a:p>
         </p:txBody>
@@ -4780,7 +4780,7 @@
                 </a:solidFill>
                 <a:latin typeface="Calibri"/>
               </a:rPr>
-              <a:t>Notebook:</a:t>
+              <a:t>Notebook: </a:t>
             </a:r>
             <a:r>
               <a:rPr sz="1300" b="0" i="0">
@@ -4788,8 +4788,9 @@
                   <a:srgbClr val="5B6472"/>
                 </a:solidFill>
                 <a:latin typeface="Calibri"/>
-              </a:rPr>
-              <a:t> Ruthvik_Nath_Bandari_Phishing_Detective.ipynb (Google Colab) · https://colab.research.google.com/drive/1kLUIs3FJafw0vvu0TI55hswcTkTR9-u4?usp=sharing</a:t>
+                <a:hlinkClick r:id="rId3"/>
+              </a:rPr>
+              <a:t>Ruthvik_Nath_Bandari_Phishing_Detective.ipynb (Google Colab) · https://colab.research.google.com/drive/1kLUIs3FJafw0vvu0TI55hswcTkTR9-u4?usp=sharing</a:t>
             </a:r>
           </a:p>
         </p:txBody>

</xml_diff>